<commit_message>
Chapter 6: fix slides 58-59 for the instructor's study confusion (batch 1)
Slide 58 explains what the lookback period does (short vs long averages),
slide 59 adds the sigma filter formula and a worked numeric example, and
states plainly that the book does not resolve N vs N-1 or whether the
current bar sits in its own window. Both from the instructor's study
conversation.
</commit_message>
<xml_diff>
--- a/chapter-06/FIN1209-Chapter-06-Student-Edition.pptx
+++ b/chapter-06/FIN1209-Chapter-06-Student-Edition.pptx
@@ -25957,13 +25957,13 @@
               </a:spcAft>
             </a:pPr>
             <a:r>
-              <a:rPr sz="1800" b="0" i="0">
+              <a:rPr sz="1600" b="0" i="0">
                 <a:solidFill>
                   <a:srgbClr val="1A1A1A"/>
                 </a:solidFill>
                 <a:latin typeface="Arial"/>
               </a:rPr>
-              <a:t>The lookback period: a simple backtest may be needed to find the right filtering.</a:t>
+              <a:t>The lookback is how many bars the average covers. Short: hugs the bars closely, many signals, mostly false.</a:t>
             </a:r>
           </a:p>
           <a:p>
@@ -25979,13 +25979,13 @@
               </a:spcAft>
             </a:pPr>
             <a:r>
-              <a:rPr sz="1800" b="0" i="0">
+              <a:rPr sz="1600" b="0" i="0">
                 <a:solidFill>
                   <a:srgbClr val="1A1A1A"/>
                 </a:solidFill>
                 <a:latin typeface="Arial"/>
               </a:rPr>
-              <a:t>Some set it to the dominant trading cycle period, or half of it.</a:t>
+              <a:t>Long: slow and flat, few signals, and some turns missed. The right length sits in between.</a:t>
             </a:r>
           </a:p>
           <a:p>
@@ -26001,13 +26001,13 @@
               </a:spcAft>
             </a:pPr>
             <a:r>
-              <a:rPr sz="1800" b="0" i="0">
+              <a:rPr sz="1600" b="0" i="0">
                 <a:solidFill>
                   <a:srgbClr val="1A1A1A"/>
                 </a:solidFill>
                 <a:latin typeface="Arial"/>
               </a:rPr>
-              <a:t>Figure 6.20: spikes above the smoothed volume line, each at a top or a bottom.</a:t>
+              <a:t>Some set it to the dominant trading cycle period, or half of it; a simple backtest may be needed instead.</a:t>
             </a:r>
           </a:p>
         </p:txBody>
@@ -26020,8 +26020,8 @@
         </p:nvSpPr>
         <p:spPr>
           <a:xfrm>
-            <a:off x="777240" y="4389120"/>
-            <a:ext cx="82296" cy="725424"/>
+            <a:off x="777240" y="4709160"/>
+            <a:ext cx="82296" cy="405384"/>
           </a:xfrm>
           <a:prstGeom prst="rect">
             <a:avLst/>
@@ -26050,8 +26050,8 @@
         </p:nvSpPr>
         <p:spPr>
           <a:xfrm>
-            <a:off x="1069848" y="4425696"/>
-            <a:ext cx="4645152" cy="725424"/>
+            <a:off x="1069848" y="4745736"/>
+            <a:ext cx="4645152" cy="405384"/>
           </a:xfrm>
           <a:prstGeom prst="rect">
             <a:avLst/>
@@ -26076,7 +26076,7 @@
               </a:spcAft>
             </a:pPr>
             <a:r>
-              <a:rPr sz="1900" b="1" i="0">
+              <a:rPr sz="1700" b="1" i="0">
                 <a:solidFill>
                   <a:srgbClr val="1A1A1A"/>
                 </a:solidFill>
@@ -26127,7 +26127,7 @@
                 </a:solidFill>
                 <a:latin typeface="Arial"/>
               </a:rPr>
-              <a:t>Backtest: run a method on past prices. Cycle period: how long a swing takes. Both Chapter 5. Dominant: undefined; our reading, the cycle most visible on the chart.</a:t>
+              <a:t>Backtest: run a method on past prices. Cycle period: how long a swing takes. Both Chapter 5.</a:t>
             </a:r>
           </a:p>
         </p:txBody>
@@ -26629,7 +26629,7 @@
         <p:spPr>
           <a:xfrm>
             <a:off x="777240" y="2258568"/>
-            <a:ext cx="64008" cy="719328"/>
+            <a:ext cx="64008" cy="688848"/>
           </a:xfrm>
           <a:prstGeom prst="rect">
             <a:avLst/>
@@ -26659,7 +26659,7 @@
         <p:spPr>
           <a:xfrm>
             <a:off x="1051560" y="2212848"/>
-            <a:ext cx="5760720" cy="829056"/>
+            <a:ext cx="5760720" cy="798576"/>
           </a:xfrm>
           <a:prstGeom prst="rect">
             <a:avLst/>
@@ -26706,13 +26706,13 @@
               </a:spcAft>
             </a:pPr>
             <a:r>
-              <a:rPr sz="1700" b="1" i="0">
+              <a:rPr sz="1600" b="1" i="0">
                 <a:solidFill>
                   <a:srgbClr val="1A1A1A"/>
                 </a:solidFill>
                 <a:latin typeface="Arial"/>
               </a:rPr>
-              <a:t>A line two or three standard deviations above average volume: only surges that cross it count.</a:t>
+              <a:t>A rolling line: Upper = average + k x standard deviation, recomputed each bar from its last N bars.</a:t>
             </a:r>
           </a:p>
         </p:txBody>
@@ -26725,8 +26725,8 @@
         </p:nvSpPr>
         <p:spPr>
           <a:xfrm>
-            <a:off x="777240" y="3233927"/>
-            <a:ext cx="64008" cy="719328"/>
+            <a:off x="777240" y="3203447"/>
+            <a:ext cx="64008" cy="932688"/>
           </a:xfrm>
           <a:prstGeom prst="rect">
             <a:avLst/>
@@ -26755,8 +26755,8 @@
         </p:nvSpPr>
         <p:spPr>
           <a:xfrm>
-            <a:off x="1051560" y="3188207"/>
-            <a:ext cx="5760720" cy="829056"/>
+            <a:off x="1051560" y="3157728"/>
+            <a:ext cx="5760720" cy="1042415"/>
           </a:xfrm>
           <a:prstGeom prst="rect">
             <a:avLst/>
@@ -26803,13 +26803,13 @@
               </a:spcAft>
             </a:pPr>
             <a:r>
-              <a:rPr sz="1700" b="0" i="0">
+              <a:rPr sz="1600" b="0" i="0">
                 <a:solidFill>
                   <a:srgbClr val="1A1A1A"/>
                 </a:solidFill>
                 <a:latin typeface="Arial"/>
               </a:rPr>
-              <a:t>Our chart: the 20-bar average plus three standard deviations of those bars. Three bars cross it.</a:t>
+              <a:t>Worked, ours, N=5: volumes 8, 10, 12, 9, 11 million. Average 10, standard deviation 1.41. Upper = 10 + 3x1.41 = 14.2 million: 15 crosses, 12 does not.</a:t>
             </a:r>
           </a:p>
         </p:txBody>
@@ -26822,8 +26822,8 @@
         </p:nvSpPr>
         <p:spPr>
           <a:xfrm>
-            <a:off x="777240" y="4209287"/>
-            <a:ext cx="64008" cy="1237488"/>
+            <a:off x="777240" y="4392167"/>
+            <a:ext cx="64008" cy="1176528"/>
           </a:xfrm>
           <a:prstGeom prst="rect">
             <a:avLst/>
@@ -26852,8 +26852,8 @@
         </p:nvSpPr>
         <p:spPr>
           <a:xfrm>
-            <a:off x="1051560" y="4163567"/>
-            <a:ext cx="5760720" cy="1347216"/>
+            <a:off x="1051560" y="4346448"/>
+            <a:ext cx="5760720" cy="1286256"/>
           </a:xfrm>
           <a:prstGeom prst="rect">
             <a:avLst/>
@@ -26900,13 +26900,13 @@
               </a:spcAft>
             </a:pPr>
             <a:r>
-              <a:rPr sz="1700" b="0" i="0">
+              <a:rPr sz="1600" b="0" i="0">
                 <a:solidFill>
                   <a:srgbClr val="1A1A1A"/>
                 </a:solidFill>
                 <a:latin typeface="Arial"/>
               </a:rPr>
-              <a:t>A two- or three-standard deviation, or sigma, filter, also called a volatility filter, keeps only the most significant surges: a 2 or 3 standard deviation Bollinger Band on volume, upper band only.</a:t>
+              <a:t>A 2- or 3-sigma filter, also a volatility filter, keeps only the most significant surges: a Bollinger Band on volume, upper band only. The book does not say N or N-1, or whether the bar is in its own window.</a:t>
             </a:r>
           </a:p>
         </p:txBody>

</xml_diff>

<commit_message>
Chapter 6: fix slide 87 for the two-dimensional volume jump (batch 2)
Slides 60 to 136 were read in full against the house teaching bar; nearly
all of it already met the bar from the first build (chapter-06/README.md).
Slide 87, "Volume by price and volume by time," gets one clause flagging
the shift away from the tick volume and TRIN slides before it. No answers
changed.
</commit_message>
<xml_diff>
--- a/chapter-06/FIN1209-Chapter-06-Student-Edition.pptx
+++ b/chapter-06/FIN1209-Chapter-06-Student-Edition.pptx
@@ -38789,7 +38789,7 @@
         <p:spPr>
           <a:xfrm>
             <a:off x="777240" y="2258568"/>
-            <a:ext cx="64008" cy="719328"/>
+            <a:ext cx="64008" cy="1115568"/>
           </a:xfrm>
           <a:prstGeom prst="rect">
             <a:avLst/>
@@ -38819,7 +38819,7 @@
         <p:spPr>
           <a:xfrm>
             <a:off x="1051560" y="2212848"/>
-            <a:ext cx="5760720" cy="829056"/>
+            <a:ext cx="5760720" cy="1225296"/>
           </a:xfrm>
           <a:prstGeom prst="rect">
             <a:avLst/>
@@ -38866,13 +38866,13 @@
               </a:spcAft>
             </a:pPr>
             <a:r>
-              <a:rPr sz="1700" b="1" i="0">
+              <a:rPr sz="1500" b="1" i="0">
                 <a:solidFill>
                   <a:srgbClr val="1A1A1A"/>
                 </a:solidFill>
                 <a:latin typeface="Arial"/>
               </a:rPr>
-              <a:t>By time: the usual bars, one a period. By price: sideways bars, one per price level.</a:t>
+              <a:t>A different split from the tick and the TRIN: not a breadth count, but one share count sliced two ways. By time: the usual bars, one a period. By price: sideways bars, one per price level.</a:t>
             </a:r>
           </a:p>
         </p:txBody>
@@ -38885,8 +38885,8 @@
         </p:nvSpPr>
         <p:spPr>
           <a:xfrm>
-            <a:off x="777240" y="3233927"/>
-            <a:ext cx="64008" cy="978408"/>
+            <a:off x="777240" y="3630168"/>
+            <a:ext cx="64008" cy="886968"/>
           </a:xfrm>
           <a:prstGeom prst="rect">
             <a:avLst/>
@@ -38915,8 +38915,8 @@
         </p:nvSpPr>
         <p:spPr>
           <a:xfrm>
-            <a:off x="1051560" y="3188207"/>
-            <a:ext cx="5760720" cy="1088136"/>
+            <a:off x="1051560" y="3584448"/>
+            <a:ext cx="5760720" cy="996696"/>
           </a:xfrm>
           <a:prstGeom prst="rect">
             <a:avLst/>
@@ -38963,7 +38963,7 @@
               </a:spcAft>
             </a:pPr>
             <a:r>
-              <a:rPr sz="1700" b="0" i="0">
+              <a:rPr sz="1500" b="0" i="0">
                 <a:solidFill>
                   <a:srgbClr val="1A1A1A"/>
                 </a:solidFill>
@@ -38982,8 +38982,8 @@
         </p:nvSpPr>
         <p:spPr>
           <a:xfrm>
-            <a:off x="777240" y="4468367"/>
-            <a:ext cx="64008" cy="1237488"/>
+            <a:off x="777240" y="4773168"/>
+            <a:ext cx="64008" cy="886968"/>
           </a:xfrm>
           <a:prstGeom prst="rect">
             <a:avLst/>
@@ -39012,8 +39012,8 @@
         </p:nvSpPr>
         <p:spPr>
           <a:xfrm>
-            <a:off x="1051560" y="4422647"/>
-            <a:ext cx="5760720" cy="1347216"/>
+            <a:off x="1051560" y="4727448"/>
+            <a:ext cx="5760720" cy="996696"/>
           </a:xfrm>
           <a:prstGeom prst="rect">
             <a:avLst/>
@@ -39060,7 +39060,7 @@
               </a:spcAft>
             </a:pPr>
             <a:r>
-              <a:rPr sz="1700" b="0" i="0">
+              <a:rPr sz="1500" b="0" i="0">
                 <a:solidFill>
                   <a:srgbClr val="1A1A1A"/>
                 </a:solidFill>

</xml_diff>

<commit_message>
Chapter 6 P3B: fix the fresh reader's six failing slides
Slide 62 no longer claims a crossing count the figure cannot show. It
names the two unlabelled lower lines and the April 2011 top the
stricter line misses. Its follow-on says Figure 6.21's window is far
longer than 20 bars, and how to pick N.

Chart V on the term slide now shows only which turns count. A new Chart
VA, with bar numbers, labelled points and the rise measured, sits beside
the step by step slide, whose step 2 now states both of the book's
rules for the threshold.

The silver slide counts two arrows, not three. Its follow-on defines
the 28 bars, names the other silver bars that reach the line, and ends
on what to do. Figure 6.23's slide names the ovals and glosses valid.

Checks and answers are unchanged. The deck holds 45 charts of ours.
</commit_message>
<xml_diff>
--- a/chapter-06/FIN1209-Chapter-06-Student-Edition.pptx
+++ b/chapter-06/FIN1209-Chapter-06-Student-Edition.pptx
@@ -30705,7 +30705,7 @@
                 </a:solidFill>
                 <a:latin typeface="Arial"/>
               </a:rPr>
-              <a:t>The three-sigma filter, run on the book's daily USDJPY chart.</a:t>
+              <a:t>Stepped line: the three-sigma filter, on daily USDJPY. The book marks three surges over it, arrows up to price.</a:t>
             </a:r>
           </a:p>
           <a:p>
@@ -30727,7 +30727,7 @@
                 </a:solidFill>
                 <a:latin typeface="Arial"/>
               </a:rPr>
-              <a:t>Each arrow runs from a bar crossing the stepped 3-sigma line up to price that day. Only three cross.</a:t>
+              <a:t>Figure 6.20, same market, marked six. Stricter, this line skips the April 2011 top, the highest price, that 6.20 caught.</a:t>
             </a:r>
           </a:p>
           <a:p>
@@ -30749,7 +30749,7 @@
                 </a:solidFill>
                 <a:latin typeface="Arial"/>
               </a:rPr>
-              <a:t>Figure 6.20, same market: many bars cross its smoothed average; the book marks six. This line is stricter.</a:t>
+              <a:t>The two lower lines are drawn and not named by the book; only the top one is the filter.</a:t>
             </a:r>
           </a:p>
         </p:txBody>
@@ -31065,7 +31065,7 @@
                 </a:solidFill>
                 <a:latin typeface="Arial"/>
               </a:rPr>
-              <a:t>Book p.189 and Figure 6.21. Ours: the counts of crossings and arrows, read off Figures 6.20 and 6.21.</a:t>
+              <a:t>Book p.189 and Figure 6.21. Ours: the counts of arrows and the April top, read off Figures 6.20 and 6.21.</a:t>
             </a:r>
           </a:p>
         </p:txBody>
@@ -31352,7 +31352,7 @@
                 </a:solidFill>
                 <a:latin typeface="Arial"/>
               </a:rPr>
-              <a:t>Two things the book leaves out: the N behind Figure 6.21's line, and how it chose Figure 6.20's six arrows.</a:t>
+              <a:t>Figure 6.21's line stays high for months after the March spike, far beyond our 20 bars. The book never gives its N.</a:t>
             </a:r>
           </a:p>
         </p:txBody>
@@ -31427,7 +31427,7 @@
                 </a:solidFill>
                 <a:latin typeface="Arial"/>
               </a:rPr>
-              <a:t>What to do: draw the 3-sigma line over the volume bars. A bar above it may mark a top or a bottom.</a:t>
+              <a:t>What to do: pick N as for the smoothed filter, then draw the 3-sigma line over the bars. A bar above it may mark a top or bottom.</a:t>
             </a:r>
           </a:p>
         </p:txBody>
@@ -32561,7 +32561,7 @@
                 </a:solidFill>
                 <a:latin typeface="Arial"/>
               </a:rPr>
-              <a:t>Ours, in millions: 1, 2, 3 came on 3.0, above our 2.5 threshold line. Six grey turns came on 1.0: dropped.</a:t>
+              <a:t>Ours, in millions: 1, 2, 3 came on 3.0, above our 2.5 line. Seven grey turns came on 1.0: dropped.</a:t>
             </a:r>
           </a:p>
         </p:txBody>
@@ -32804,7 +32804,7 @@
                 </a:solidFill>
                 <a:latin typeface="Arial"/>
               </a:rPr>
-              <a:t>Book p.189. Inflection point, trendline and channel: Chapter 5. The chart is ours, invented.</a:t>
+              <a:t>Book p.189. Inflection point: Chapter 5. The chart is ours, invented.</a:t>
             </a:r>
           </a:p>
         </p:txBody>
@@ -33016,104 +33016,104 @@
         <p:spPr>
           <a:xfrm>
             <a:off x="777240" y="1965960"/>
-            <a:ext cx="10637215" cy="3108960"/>
-          </a:xfrm>
-          <a:prstGeom prst="rect">
-            <a:avLst/>
-          </a:prstGeom>
-          <a:noFill/>
-        </p:spPr>
-        <p:txBody>
-          <a:bodyPr wrap="square" anchor="t" lIns="0" rIns="0" tIns="0" bIns="0">
-            <a:spAutoFit/>
-          </a:bodyPr>
-          <a:lstStyle/>
-          <a:p>
-            <a:pPr algn="l">
-              <a:lnSpc>
-                <a:spcPct val="118000"/>
-              </a:lnSpc>
-              <a:spcBef>
-                <a:spcPts val="0"/>
-              </a:spcBef>
-              <a:spcAft>
-                <a:spcPts val="1300"/>
-              </a:spcAft>
-            </a:pPr>
-            <a:r>
-              <a:rPr sz="2100" b="0" i="0">
+            <a:ext cx="5120640" cy="3108960"/>
+          </a:xfrm>
+          <a:prstGeom prst="rect">
+            <a:avLst/>
+          </a:prstGeom>
+          <a:noFill/>
+        </p:spPr>
+        <p:txBody>
+          <a:bodyPr wrap="square" anchor="t" lIns="0" rIns="0" tIns="0" bIns="0">
+            <a:spAutoFit/>
+          </a:bodyPr>
+          <a:lstStyle/>
+          <a:p>
+            <a:pPr algn="l">
+              <a:lnSpc>
+                <a:spcPct val="105000"/>
+              </a:lnSpc>
+              <a:spcBef>
+                <a:spcPts val="0"/>
+              </a:spcBef>
+              <a:spcAft>
+                <a:spcPts val="1100"/>
+              </a:spcAft>
+            </a:pPr>
+            <a:r>
+              <a:rPr sz="1800" b="0" i="0">
                 <a:solidFill>
                   <a:srgbClr val="1A1A1A"/>
                 </a:solidFill>
                 <a:latin typeface="Arial"/>
               </a:rPr>
-              <a:t>Step 1. Mark every peak and trough: the gold and grey dots, nine of them.</a:t>
-            </a:r>
-          </a:p>
-          <a:p>
-            <a:pPr algn="l">
-              <a:lnSpc>
-                <a:spcPct val="118000"/>
-              </a:lnSpc>
-              <a:spcBef>
-                <a:spcPts val="0"/>
-              </a:spcBef>
-              <a:spcAft>
-                <a:spcPts val="1300"/>
-              </a:spcAft>
-            </a:pPr>
-            <a:r>
-              <a:rPr sz="2100" b="0" i="0">
+              <a:t>Step 1. Mark every peak and trough.</a:t>
+            </a:r>
+          </a:p>
+          <a:p>
+            <a:pPr algn="l">
+              <a:lnSpc>
+                <a:spcPct val="105000"/>
+              </a:lnSpc>
+              <a:spcBef>
+                <a:spcPts val="0"/>
+              </a:spcBef>
+              <a:spcAft>
+                <a:spcPts val="1100"/>
+              </a:spcAft>
+            </a:pPr>
+            <a:r>
+              <a:rPr sz="1800" b="0" i="0">
                 <a:solidFill>
                   <a:srgbClr val="1A1A1A"/>
                 </a:solidFill>
                 <a:latin typeface="Arial"/>
               </a:rPr>
-              <a:t>Step 2. By eye, draw a threshold line only the heaviest volume reaches: ours 2.5 million, average 1.3. The book gives no number. Keep 1, 2, 3.</a:t>
-            </a:r>
-          </a:p>
-          <a:p>
-            <a:pPr algn="l">
-              <a:lnSpc>
-                <a:spcPct val="118000"/>
-              </a:lnSpc>
-              <a:spcBef>
-                <a:spcPts val="0"/>
-              </a:spcBef>
-              <a:spcAft>
-                <a:spcPts val="1300"/>
-              </a:spcAft>
-            </a:pPr>
-            <a:r>
-              <a:rPr sz="2100" b="0" i="0">
+              <a:t>Step 2. The book's rule: above average volume, 1.3 here. Its example draws a higher line by eye, and it never says which governs. Ours: 2.5. Only 1, 2, 3 reach it.</a:t>
+            </a:r>
+          </a:p>
+          <a:p>
+            <a:pPr algn="l">
+              <a:lnSpc>
+                <a:spcPct val="105000"/>
+              </a:lnSpc>
+              <a:spcBef>
+                <a:spcPts val="0"/>
+              </a:spcBef>
+              <a:spcAft>
+                <a:spcPts val="1100"/>
+              </a:spcAft>
+            </a:pPr>
+            <a:r>
+              <a:rPr sz="1800" b="0" i="0">
                 <a:solidFill>
                   <a:srgbClr val="1A1A1A"/>
                 </a:solidFill>
                 <a:latin typeface="Arial"/>
               </a:rPr>
-              <a:t>Step 3. Trendline through peaks 1 (bar 22, PHP 52.00) and 2 (bar 62, PHP 56.00): up PHP 4.00 in 40 bars, 0.10 a bar.</a:t>
-            </a:r>
-          </a:p>
-          <a:p>
-            <a:pPr algn="l">
-              <a:lnSpc>
-                <a:spcPct val="118000"/>
-              </a:lnSpc>
-              <a:spcBef>
-                <a:spcPts val="0"/>
-              </a:spcBef>
-              <a:spcAft>
-                <a:spcPts val="1300"/>
-              </a:spcAft>
-            </a:pPr>
-            <a:r>
-              <a:rPr sz="2100" b="0" i="0">
+              <a:t>Step 3. Join peaks 1 (bar 22, PHP 52.00) and 2 (bar 62, PHP 56.00): PHP 4.00 in 40 bars, 0.10 a bar.</a:t>
+            </a:r>
+          </a:p>
+          <a:p>
+            <a:pPr algn="l">
+              <a:lnSpc>
+                <a:spcPct val="105000"/>
+              </a:lnSpc>
+              <a:spcBef>
+                <a:spcPts val="0"/>
+              </a:spcBef>
+              <a:spcAft>
+                <a:spcPts val="1100"/>
+              </a:spcAft>
+            </a:pPr>
+            <a:r>
+              <a:rPr sz="1800" b="0" i="0">
                 <a:solidFill>
                   <a:srgbClr val="1A1A1A"/>
                 </a:solidFill>
                 <a:latin typeface="Arial"/>
               </a:rPr>
-              <a:t>Step 4. Through trough 3 (bar 44, PHP 49.00), a parallel at the same 0.10 a bar.</a:t>
+              <a:t>Step 4. The same slope through trough 3 (bar 44, PHP 49.00): the channel.</a:t>
             </a:r>
           </a:p>
         </p:txBody>
@@ -33126,17 +33126,19 @@
         </p:nvSpPr>
         <p:spPr>
           <a:xfrm>
-            <a:off x="777240" y="5211317"/>
-            <a:ext cx="82296" cy="467614"/>
+            <a:off x="6219291" y="1810512"/>
+            <a:ext cx="5193792" cy="3749039"/>
           </a:xfrm>
           <a:prstGeom prst="rect">
             <a:avLst/>
           </a:prstGeom>
           <a:solidFill>
-            <a:srgbClr val="F2A900"/>
+            <a:srgbClr val="FFFFFF"/>
           </a:solidFill>
-          <a:ln>
-            <a:noFill/>
+          <a:ln w="12700">
+            <a:solidFill>
+              <a:srgbClr val="D7E0D9"/>
+            </a:solidFill>
           </a:ln>
           <a:effectLst/>
         </p:spPr>
@@ -33148,54 +33150,78 @@
           </a:p>
         </p:txBody>
       </p:sp>
-      <p:sp>
-        <p:nvSpPr>
-          <p:cNvPr id="9" name="TextBox 8"/>
-          <p:cNvSpPr txBox="1"/>
-          <p:nvPr/>
-        </p:nvSpPr>
-        <p:spPr>
-          <a:xfrm>
-            <a:off x="1069848" y="5247893"/>
-            <a:ext cx="10344607" cy="467614"/>
-          </a:xfrm>
-          <a:prstGeom prst="rect">
-            <a:avLst/>
-          </a:prstGeom>
-          <a:noFill/>
-        </p:spPr>
-        <p:txBody>
-          <a:bodyPr wrap="square" anchor="t" lIns="0" rIns="0" tIns="0" bIns="0">
-            <a:spAutoFit/>
-          </a:bodyPr>
-          <a:lstStyle/>
-          <a:p>
-            <a:pPr algn="l">
-              <a:lnSpc>
-                <a:spcPct val="115000"/>
-              </a:lnSpc>
-              <a:spcBef>
-                <a:spcPts val="0"/>
-              </a:spcBef>
-              <a:spcAft>
-                <a:spcPts val="0"/>
-              </a:spcAft>
-            </a:pPr>
-            <a:r>
-              <a:rPr sz="2200" b="1" i="0">
-                <a:solidFill>
-                  <a:srgbClr val="1A1A1A"/>
-                </a:solidFill>
-                <a:latin typeface="Arial"/>
-              </a:rPr>
-              <a:t>The two parallels are the channel.</a:t>
-            </a:r>
-          </a:p>
-        </p:txBody>
-      </p:sp>
+      <p:pic>
+        <p:nvPicPr>
+          <p:cNvPr id="9" name="Picture 8" descr="chart-va.png"/>
+          <p:cNvPicPr>
+            <a:picLocks noChangeAspect="1"/>
+          </p:cNvPicPr>
+          <p:nvPr/>
+        </p:nvPicPr>
+        <p:blipFill>
+          <a:blip r:embed="rId2"/>
+          <a:stretch>
+            <a:fillRect/>
+          </a:stretch>
+        </p:blipFill>
+        <p:spPr>
+          <a:xfrm>
+            <a:off x="6338163" y="1929384"/>
+            <a:ext cx="4956048" cy="3511296"/>
+          </a:xfrm>
+          <a:prstGeom prst="rect">
+            <a:avLst/>
+          </a:prstGeom>
+        </p:spPr>
+      </p:pic>
       <p:sp>
         <p:nvSpPr>
           <p:cNvPr id="10" name="TextBox 9"/>
+          <p:cNvSpPr txBox="1"/>
+          <p:nvPr/>
+        </p:nvSpPr>
+        <p:spPr>
+          <a:xfrm>
+            <a:off x="6217919" y="5650991"/>
+            <a:ext cx="5196535" cy="274320"/>
+          </a:xfrm>
+          <a:prstGeom prst="rect">
+            <a:avLst/>
+          </a:prstGeom>
+          <a:noFill/>
+        </p:spPr>
+        <p:txBody>
+          <a:bodyPr wrap="square" anchor="t" lIns="0" rIns="0" tIns="0" bIns="0">
+            <a:spAutoFit/>
+          </a:bodyPr>
+          <a:lstStyle/>
+          <a:p>
+            <a:pPr algn="l">
+              <a:lnSpc>
+                <a:spcPct val="100000"/>
+              </a:lnSpc>
+              <a:spcBef>
+                <a:spcPts val="0"/>
+              </a:spcBef>
+              <a:spcAft>
+                <a:spcPts val="0"/>
+              </a:spcAft>
+            </a:pPr>
+            <a:r>
+              <a:rPr sz="900" b="0" i="0">
+                <a:solidFill>
+                  <a:srgbClr val="818181"/>
+                </a:solidFill>
+                <a:latin typeface="Arial"/>
+              </a:rPr>
+              <a:t>Chart VA - FIN1209 teaching chart, drawn for this course. Illustrative data, not a real instrument.</a:t>
+            </a:r>
+          </a:p>
+        </p:txBody>
+      </p:sp>
+      <p:sp>
+        <p:nvSpPr>
+          <p:cNvPr id="11" name="TextBox 10"/>
           <p:cNvSpPr txBox="1"/>
           <p:nvPr/>
         </p:nvSpPr>
@@ -33233,7 +33259,7 @@
                 </a:solidFill>
                 <a:latin typeface="Arial"/>
               </a:rPr>
-              <a:t>Ours: the steps and every number, invented, as on Chart V. The method is the book's, p.189.</a:t>
+              <a:t>Ours: the steps and every number, invented. The method and both rules for the threshold are the book's, p.189.</a:t>
             </a:r>
           </a:p>
         </p:txBody>
@@ -33498,7 +33524,7 @@
                 </a:solidFill>
                 <a:latin typeface="Arial"/>
               </a:rPr>
-              <a:t>A threshold drawn by visual inspection, so only the most significant peaks reach it; the oval rings them.</a:t>
+              <a:t>A threshold drawn by visual inspection, so only the most significant peaks reach it. The oval rings July to August.</a:t>
             </a:r>
           </a:p>
           <a:p>
@@ -33520,7 +33546,7 @@
                 </a:solidFill>
                 <a:latin typeface="Arial"/>
               </a:rPr>
-              <a:t>Arrows rise to Points 1, 2 and 3, the only turns used: trendline 1 to 2, parallel from 3.</a:t>
+              <a:t>Two arrows: under Points 1 and 3, days apart, and under 2. Trendline 1 to 2, parallel from 3.</a:t>
             </a:r>
           </a:p>
         </p:txBody>
@@ -34079,7 +34105,7 @@
                 </a:solidFill>
                 <a:latin typeface="Arial"/>
               </a:rPr>
-              <a:t>At both X's, ours and the book's, price turns up at the lower line: support. Ours: 49.00 + 28 bars x 0.10 = PHP 51.80.</a:t>
+              <a:t>Ours: X is bar 72, 28 bars after trough 3 at bar 44. The lower line is there at 49.00 + 28 x 0.10 = PHP 51.80; price touches it and turns up.</a:t>
             </a:r>
           </a:p>
           <a:p>
@@ -34101,7 +34127,7 @@
                 </a:solidFill>
                 <a:latin typeface="Arial"/>
               </a:rPr>
-              <a:t>Why only heavily traded turns? The book says only: the importance of significant inflection points.</a:t>
+              <a:t>Silver's April bars (labelled High tick volume level) and late September bars reach the line too; the channel uses only July to August, unexplained.</a:t>
             </a:r>
           </a:p>
           <a:p>
@@ -34123,7 +34149,7 @@
                 </a:solidFill>
                 <a:latin typeface="Arial"/>
               </a:rPr>
-              <a:t>Part 3's first rule fits: a barrier formed at a volume peak is the most reliable. That link is ours.</a:t>
+              <a:t>Chapter 5's uptrend line joined troughs; here the book joins two peaks and gives no reason. Either way, two parallels make the channel.</a:t>
             </a:r>
           </a:p>
         </p:txBody>
@@ -34198,7 +34224,7 @@
                 </a:solidFill>
                 <a:latin typeface="Arial"/>
               </a:rPr>
-              <a:t>Chapter 5's uptrend line joined troughs. Here the book joins two peaks, parallel through a trough, and gives no reason.</a:t>
+              <a:t>What to do: at the lower line, look for a short-term buy, as at silver's X. Falling through it violates the channel.</a:t>
             </a:r>
           </a:p>
         </p:txBody>
@@ -34243,7 +34269,7 @@
                 </a:solidFill>
                 <a:latin typeface="Arial"/>
               </a:rPr>
-              <a:t>Book pp.187, 189-190. Ours: the arithmetic at X and the link to Part 3's first slide.</a:t>
+              <a:t>Book pp.189-190 and Figure 6.22. Ours: the arithmetic at X, and what the figure's volume panel shows.</a:t>
             </a:r>
           </a:p>
         </p:txBody>
@@ -34486,7 +34512,7 @@
                 </a:solidFill>
                 <a:latin typeface="Arial"/>
               </a:rPr>
-              <a:t>Points numbered afresh. Trendline 1 to 2, parallel from 3: a large bearish candlestick, closing far below its open, breaks down through it.</a:t>
+              <a:t>Points numbered afresh. Ovals ring heavy volume under 1, under 3 and 2, under 5 and 6.</a:t>
             </a:r>
           </a:p>
           <a:p>
@@ -34508,7 +34534,7 @@
                 </a:solidFill>
                 <a:latin typeface="Arial"/>
               </a:rPr>
-              <a:t>A parallel from 4, carried back, touches the trough at X, January 2011. Found looking back; the book still calls it valid.</a:t>
+              <a:t>Trendline 1 to 2, parallel from 3: a large bearish candlestick, closing far below its open, breaks it.</a:t>
             </a:r>
           </a:p>
           <a:p>
@@ -34530,7 +34556,29 @@
                 </a:solidFill>
                 <a:latin typeface="Arial"/>
               </a:rPr>
-              <a:t>Parallels from 5 and 6: a new channel, resistance at its top, support at its bottom.</a:t>
+              <a:t>A parallel from 4, carried back, meets the trough at X, January 2011: valid, the book says, with no third touch (Chapter 5).</a:t>
+            </a:r>
+          </a:p>
+          <a:p>
+            <a:pPr algn="l">
+              <a:lnSpc>
+                <a:spcPct val="105000"/>
+              </a:lnSpc>
+              <a:spcBef>
+                <a:spcPts val="0"/>
+              </a:spcBef>
+              <a:spcAft>
+                <a:spcPts val="1100"/>
+              </a:spcAft>
+            </a:pPr>
+            <a:r>
+              <a:rPr sz="1700" b="0" i="0">
+                <a:solidFill>
+                  <a:srgbClr val="1A1A1A"/>
+                </a:solidFill>
+                <a:latin typeface="Arial"/>
+              </a:rPr>
+              <a:t>Parallels from 5 and 6: a new channel.</a:t>
             </a:r>
           </a:p>
         </p:txBody>
@@ -34543,7 +34591,7 @@
         </p:nvSpPr>
         <p:spPr>
           <a:xfrm>
-            <a:off x="777240" y="5109210"/>
+            <a:off x="777240" y="5273802"/>
             <a:ext cx="82296" cy="420623"/>
           </a:xfrm>
           <a:prstGeom prst="rect">
@@ -34573,7 +34621,7 @@
         </p:nvSpPr>
         <p:spPr>
           <a:xfrm>
-            <a:off x="1069848" y="5145786"/>
+            <a:off x="1069848" y="5310378"/>
             <a:ext cx="4828032" cy="420623"/>
           </a:xfrm>
           <a:prstGeom prst="rect">
@@ -34846,7 +34894,7 @@
                 </a:solidFill>
                 <a:latin typeface="Arial"/>
               </a:rPr>
-              <a:t>Book pp.189-190 and Figure 6.23. Candlestick: Chapter 3.</a:t>
+              <a:t>Book pp.189-190 and Figure 6.23. Candlestick and valid: Chapters 3 and 5.</a:t>
             </a:r>
           </a:p>
         </p:txBody>
@@ -35111,7 +35159,7 @@
                 </a:solidFill>
                 <a:latin typeface="Arial"/>
               </a:rPr>
-              <a:t>Its lesson: the importance of constructing chart patterns based on significant inflection points.</a:t>
+              <a:t>The 5 and 6 channel: resistance at its top, support at its bottom. The book's lesson: build patterns on significant inflection points.</a:t>
             </a:r>
           </a:p>
           <a:p>

</xml_diff>